<commit_message>
el nivel difícil evalúa posición y no pasea al rey
</commit_message>
<xml_diff>
--- a/docs/presentacion.pptx
+++ b/docs/presentacion.pptx
@@ -1135,7 +1135,7 @@
           <a:p>
             <a:r>
               <a:rPr lang="en-US" dirty="0"/>
-              <a:t>La IA no forma parte de las reglas, por eso vive en el paquete ai y solo conoce IChessGame. Piensa sobre una copia de la partida, así que nunca toca la pantalla. El nivel difícil es un minimax de dos jugadas con el material como evaluación; no ve más allá de eso y puede equivocarse con el enroque, porque la copia no tiene historial.</a:t>
+              <a:t>La IA no forma parte de las reglas, por eso vive en el paquete ai y solo conoce IChessGame. Piensa sobre una copia de la partida, así que nunca toca la pantalla. El nivel difícil es un minimax de dos jugadas que evalúa con el material y un poco de criterio posicional (centro, desarrollo, seguridad del rey); no ve más allá de dos jugadas y puede equivocarse con el enroque, porque la copia no tiene historial.</a:t>
             </a:r>
             <a:endParaRPr lang="en-US" dirty="0"/>
           </a:p>
@@ -9151,7 +9151,7 @@
                 <a:ea typeface="Calibri" pitchFamily="34" charset="-122"/>
                 <a:cs typeface="Calibri" pitchFamily="34" charset="-120"/>
               </a:rPr>
-              <a:t>Prueba su jugada y la respuesta del rival, y se queda con la que deja mejor material.</a:t>
+              <a:t>Prueba su jugada y la respuesta del rival, y se queda con la que deja mejor material y posición.</a:t>
             </a:r>
             <a:endParaRPr lang="en-US" sz="1600" dirty="0"/>
           </a:p>
@@ -9279,7 +9279,7 @@
                 <a:ea typeface="Calibri" pitchFamily="34" charset="-122"/>
                 <a:cs typeface="Calibri" pitchFamily="34" charset="-120"/>
               </a:rPr>
-              <a:t>Puntaje: material propio menos material rival; el mate vale más que todo</a:t>
+              <a:t>Puntaje: material más centro, desarrollo y rey seguro; el mate vale más que todo</a:t>
             </a:r>
             <a:endParaRPr lang="en-US" sz="1700" dirty="0"/>
           </a:p>

</xml_diff>

<commit_message>
La vista recibe la partida armada por GameBuilder, ventana adaptada al tamano del tablero y documentacion al dia
</commit_message>
<xml_diff>
--- a/docs/presentacion.pptx
+++ b/docs/presentacion.pptx
@@ -23,9 +23,10 @@
     <p:sldId id="271" r:id="rId17"/>
     <p:sldId id="272" r:id="rId18"/>
     <p:sldId id="273" r:id="rId19"/>
+    <p:sldId id="274" r:id="rId20"/>
   </p:sldIdLst>
   <p:notesMasterIdLst>
-    <p:notesMasterId r:id="rId20"/>
+    <p:notesMasterId r:id="rId21"/>
   </p:notesMasterIdLst>
   <p:sldSz cx="12192000" cy="6858000"/>
   <p:notesSz cx="6858000" cy="12192000"/>
@@ -1223,7 +1224,7 @@
           <a:p>
             <a:r>
               <a:rPr lang="en-US" dirty="0"/>
-              <a:t>Resumen del documento de justificación: cada decisión se explica en tres partes, qué, por qué y cuándo se rompería. Acá va solo la primera y la última. El detalle está en docs/justificacion.</a:t>
+              <a:t>Las cuentas no son reglas del ajedrez: viven en el paquete usuarios. ScoreRecorder escucha la partida con los mismos listeners que la consola y la ventana, y acredita el resultado. Guardar es un puerto, IAccountStore; hoy lo implementa un CSV y mañana podría ser una base de datos sin cambiar nada más.</a:t>
             </a:r>
             <a:endParaRPr lang="en-US" dirty="0"/>
           </a:p>
@@ -1311,7 +1312,7 @@
           <a:p>
             <a:r>
               <a:rPr lang="en-US" dirty="0"/>
-              <a:t>Demostración en vivo: abrir MainSwing. Mostrar dos jugadores con enroque, coronación y captura al paso; después deshacer y rehacer; después jugar contra la IA en nivel difícil. Cerrar mostrando en el código cómo se suma una pieza nueva.</a:t>
+              <a:t>Resumen del documento de justificación: cada decisión se explica en tres partes, qué, por qué y cuándo se rompería. Acá va solo la primera y la última. El detalle está en docs/justificacion.</a:t>
             </a:r>
             <a:endParaRPr lang="en-US" dirty="0"/>
           </a:p>
@@ -1335,6 +1336,94 @@
             <a:fld id="{F7021451-1387-4CA6-816F-3879F97B5CBC}" type="slidenum">
               <a:rPr lang="en-US"/>
               <a:t>18</a:t>
+            </a:fld>
+            <a:endParaRPr lang="en-US"/>
+          </a:p>
+        </p:txBody>
+      </p:sp>
+    </p:spTree>
+    <p:extLst>
+      <p:ext uri="{BB962C8B-B14F-4D97-AF65-F5344CB8AC3E}">
+        <p14:creationId xmlns:p14="http://schemas.microsoft.com/office/powerpoint/2010/main" val="1024086991"/>
+      </p:ext>
+    </p:extLst>
+  </p:cSld>
+  <p:clrMapOvr>
+    <a:masterClrMapping/>
+  </p:clrMapOvr>
+</p:notes>
+</file>
+
+<file path=ppt/notesSlides/notesSlide19.xml><?xml version="1.0" encoding="utf-8"?>
+<p:notes xmlns:a="http://schemas.openxmlformats.org/drawingml/2006/main" xmlns:r="http://schemas.openxmlformats.org/officeDocument/2006/relationships" xmlns:p="http://schemas.openxmlformats.org/presentationml/2006/main">
+  <p:cSld>
+    <p:spTree>
+      <p:nvGrpSpPr>
+        <p:cNvPr id="1" name=""/>
+        <p:cNvGrpSpPr/>
+        <p:nvPr/>
+      </p:nvGrpSpPr>
+      <p:grpSpPr>
+        <a:xfrm>
+          <a:off x="0" y="0"/>
+          <a:ext cx="0" cy="0"/>
+          <a:chOff x="0" y="0"/>
+          <a:chExt cx="0" cy="0"/>
+        </a:xfrm>
+      </p:grpSpPr>
+      <p:sp>
+        <p:nvSpPr>
+          <p:cNvPr id="2" name="Slide Image Placeholder 1"/>
+          <p:cNvSpPr>
+            <a:spLocks noGrp="1" noRot="1" noChangeAspect="1"/>
+          </p:cNvSpPr>
+          <p:nvPr>
+            <p:ph type="sldImg"/>
+          </p:nvPr>
+        </p:nvSpPr>
+        <p:spPr/>
+      </p:sp>
+      <p:sp>
+        <p:nvSpPr>
+          <p:cNvPr id="3" name="Notes Placeholder 2"/>
+          <p:cNvSpPr>
+            <a:spLocks noGrp="1"/>
+          </p:cNvSpPr>
+          <p:nvPr>
+            <p:ph type="body" idx="1"/>
+          </p:nvPr>
+        </p:nvSpPr>
+        <p:spPr/>
+        <p:txBody>
+          <a:bodyPr/>
+          <a:lstStyle/>
+          <a:p>
+            <a:r>
+              <a:rPr lang="en-US" dirty="0"/>
+              <a:t>Demostración en vivo: abrir MainSwing. En el menú, registrar dos usuarios y jugar 1 contra 1 con enroque, coronación y captura al paso; deshacer y rehacer; ver el ranking. Después, contra la IA en nivel difícil jugando con negras (el tablero se gira). Cerrar mostrando en el código cómo se suma una pieza nueva.</a:t>
+            </a:r>
+            <a:endParaRPr lang="en-US" dirty="0"/>
+          </a:p>
+        </p:txBody>
+      </p:sp>
+      <p:sp>
+        <p:nvSpPr>
+          <p:cNvPr id="4" name="Slide Number Placeholder 3"/>
+          <p:cNvSpPr>
+            <a:spLocks noGrp="1"/>
+          </p:cNvSpPr>
+          <p:nvPr>
+            <p:ph type="sldNum" sz="quarter" idx="10"/>
+          </p:nvPr>
+        </p:nvSpPr>
+        <p:spPr/>
+        <p:txBody>
+          <a:bodyPr/>
+          <a:lstStyle/>
+          <a:p>
+            <a:fld id="{F7021451-1387-4CA6-816F-3879F97B5CBC}" type="slidenum">
+              <a:rPr lang="en-US"/>
+              <a:t>19</a:t>
             </a:fld>
             <a:endParaRPr lang="en-US"/>
           </a:p>
@@ -1751,7 +1840,7 @@
           <a:p>
             <a:r>
               <a:rPr lang="en-US" dirty="0"/>
-              <a:t>El mundo exterior le habla al núcleo por una sola interfaz, IChessGame, aunque haya teclado, mouse y IA. El núcleo le habla al exterior por tres puertos chicos: lo que pasa con las piezas, el estado de la partida y a qué pieza se corona.</a:t>
+              <a:t>El mundo exterior le habla al núcleo por una sola interfaz, IChessGame, aunque haya teclado, mouse y IA. Hacia afuera hay un puerto chico por cada cosa que se pide: lo que pasa con las piezas, el estado de la partida, a qué pieza se corona y dónde se guardan los usuarios.</a:t>
             </a:r>
             <a:endParaRPr lang="en-US" dirty="0"/>
           </a:p>
@@ -2631,7 +2720,7 @@
         <p:spPr>
           <a:xfrm>
             <a:off x="6858000" y="585216"/>
-            <a:ext cx="5005047" cy="5687568"/>
+            <a:ext cx="5279050" cy="5687568"/>
           </a:xfrm>
           <a:prstGeom prst="rect">
             <a:avLst/>
@@ -2664,7 +2753,7 @@
         <p:spPr>
           <a:xfrm>
             <a:off x="6912864" y="640080"/>
-            <a:ext cx="4895319" cy="5577840"/>
+            <a:ext cx="5169322" cy="5577840"/>
           </a:xfrm>
           <a:prstGeom prst="rect">
             <a:avLst/>
@@ -8114,7 +8203,7 @@
                 <a:ea typeface="Cambria" pitchFamily="34" charset="-122"/>
                 <a:cs typeface="Cambria" pitchFamily="34" charset="-120"/>
               </a:rPr>
-              <a:t>63</a:t>
+              <a:t>65</a:t>
             </a:r>
             <a:endParaRPr lang="en-US" sz="13000" dirty="0"/>
           </a:p>
@@ -8153,7 +8242,7 @@
                 <a:ea typeface="Calibri" pitchFamily="34" charset="-122"/>
                 <a:cs typeface="Calibri" pitchFamily="34" charset="-120"/>
               </a:rPr>
-              <a:t>tests del núcleo, todos pasan</a:t>
+              <a:t>tests del núcleo y 20 de usuarios, todos pasan</a:t>
             </a:r>
             <a:endParaRPr lang="en-US" sz="2000" dirty="0"/>
           </a:p>
@@ -8345,7 +8434,7 @@
                 <a:ea typeface="Calibri" pitchFamily="34" charset="-122"/>
                 <a:cs typeface="Calibri" pitchFamily="34" charset="-120"/>
               </a:rPr>
-              <a:t>Un stub y un mock como dobles de prueba</a:t>
+              <a:t>Un stub, un mock y un fake como dobles de prueba</a:t>
             </a:r>
             <a:endParaRPr lang="en-US" sz="1700" dirty="0"/>
           </a:p>
@@ -8537,7 +8626,7 @@
                 <a:ea typeface="Calibri" pitchFamily="34" charset="-122"/>
                 <a:cs typeface="Calibri" pitchFamily="34" charset="-120"/>
               </a:rPr>
-              <a:t>Pruebas de integración de la ventana Swing</a:t>
+              <a:t>Pruebas de integración de la consola y de la ventana Swing</a:t>
             </a:r>
             <a:endParaRPr lang="en-US" sz="1700" dirty="0"/>
           </a:p>
@@ -9350,7 +9439,7 @@
                 <a:ea typeface="Calibri" pitchFamily="34" charset="-122"/>
                 <a:cs typeface="Calibri" pitchFamily="34" charset="-120"/>
               </a:rPr>
-              <a:t>DECISIONES</a:t>
+              <a:t>USUARIOS Y RANKING</a:t>
             </a:r>
             <a:endParaRPr lang="en-US" sz="1200" dirty="0"/>
           </a:p>
@@ -9389,7 +9478,7 @@
                 <a:ea typeface="Cambria" pitchFamily="34" charset="-122"/>
                 <a:cs typeface="Cambria" pitchFamily="34" charset="-120"/>
               </a:rPr>
-              <a:t>Qué se decidió y cuándo se rompería</a:t>
+              <a:t>Un puerto de salida más, sin tocar el núcleo</a:t>
             </a:r>
             <a:endParaRPr lang="en-US" sz="3000" dirty="0"/>
           </a:p>
@@ -9473,9 +9562,1008 @@
           </a:p>
         </p:txBody>
       </p:sp>
+      <p:sp>
+        <p:nvSpPr>
+          <p:cNvPr id="7" name="Shape 4"/>
+          <p:cNvSpPr/>
+          <p:nvPr/>
+        </p:nvSpPr>
+        <p:spPr>
+          <a:xfrm>
+            <a:off x="640080" y="1828800"/>
+            <a:ext cx="2377440" cy="731520"/>
+          </a:xfrm>
+          <a:prstGeom prst="rect">
+            <a:avLst/>
+          </a:prstGeom>
+          <a:solidFill>
+            <a:srgbClr val="FFFFFF"/>
+          </a:solidFill>
+          <a:ln w="12700">
+            <a:solidFill>
+              <a:srgbClr val="D4D8CC"/>
+            </a:solidFill>
+            <a:prstDash val="solid"/>
+          </a:ln>
+        </p:spPr>
+      </p:sp>
+      <p:sp>
+        <p:nvSpPr>
+          <p:cNvPr id="8" name="Text 5"/>
+          <p:cNvSpPr/>
+          <p:nvPr/>
+        </p:nvSpPr>
+        <p:spPr>
+          <a:xfrm>
+            <a:off x="640080" y="1828800"/>
+            <a:ext cx="2377440" cy="731520"/>
+          </a:xfrm>
+          <a:prstGeom prst="rect">
+            <a:avLst/>
+          </a:prstGeom>
+          <a:noFill/>
+          <a:ln/>
+        </p:spPr>
+        <p:txBody>
+          <a:bodyPr wrap="square" lIns="762" tIns="762" rIns="762" bIns="762" rtlCol="0" anchor="ctr"/>
+          <a:lstStyle/>
+          <a:p>
+            <a:pPr algn="ctr" indent="0" marL="0">
+              <a:buNone/>
+            </a:pPr>
+            <a:r>
+              <a:rPr lang="en-US" sz="1400" b="1" dirty="0">
+                <a:solidFill>
+                  <a:srgbClr val="1F2933"/>
+                </a:solidFill>
+                <a:latin typeface="Courier New" pitchFamily="34" charset="0"/>
+                <a:ea typeface="Courier New" pitchFamily="34" charset="-122"/>
+                <a:cs typeface="Courier New" pitchFamily="34" charset="-120"/>
+              </a:rPr>
+              <a:t>ChessGame</a:t>
+            </a:r>
+            <a:endParaRPr lang="en-US" sz="1400" dirty="0"/>
+          </a:p>
+        </p:txBody>
+      </p:sp>
+      <p:sp>
+        <p:nvSpPr>
+          <p:cNvPr id="9" name="Shape 6"/>
+          <p:cNvSpPr/>
+          <p:nvPr/>
+        </p:nvSpPr>
+        <p:spPr>
+          <a:xfrm>
+            <a:off x="3657600" y="1828800"/>
+            <a:ext cx="2651760" cy="731520"/>
+          </a:xfrm>
+          <a:prstGeom prst="rect">
+            <a:avLst/>
+          </a:prstGeom>
+          <a:solidFill>
+            <a:srgbClr val="EAF0E4"/>
+          </a:solidFill>
+          <a:ln w="19050">
+            <a:solidFill>
+              <a:srgbClr val="466A38"/>
+            </a:solidFill>
+            <a:prstDash val="solid"/>
+          </a:ln>
+        </p:spPr>
+      </p:sp>
+      <p:sp>
+        <p:nvSpPr>
+          <p:cNvPr id="10" name="Text 7"/>
+          <p:cNvSpPr/>
+          <p:nvPr/>
+        </p:nvSpPr>
+        <p:spPr>
+          <a:xfrm>
+            <a:off x="3657600" y="1828800"/>
+            <a:ext cx="2651760" cy="731520"/>
+          </a:xfrm>
+          <a:prstGeom prst="rect">
+            <a:avLst/>
+          </a:prstGeom>
+          <a:noFill/>
+          <a:ln/>
+        </p:spPr>
+        <p:txBody>
+          <a:bodyPr wrap="square" lIns="762" tIns="762" rIns="762" bIns="762" rtlCol="0" anchor="ctr"/>
+          <a:lstStyle/>
+          <a:p>
+            <a:pPr algn="ctr" indent="0" marL="0">
+              <a:buNone/>
+            </a:pPr>
+            <a:r>
+              <a:rPr lang="en-US" sz="1300" b="1" dirty="0">
+                <a:solidFill>
+                  <a:srgbClr val="1F2933"/>
+                </a:solidFill>
+                <a:latin typeface="Courier New" pitchFamily="34" charset="0"/>
+                <a:ea typeface="Courier New" pitchFamily="34" charset="-122"/>
+                <a:cs typeface="Courier New" pitchFamily="34" charset="-120"/>
+              </a:rPr>
+              <a:t>ScoreRecorder</a:t>
+            </a:r>
+            <a:endParaRPr lang="en-US" sz="1300" dirty="0"/>
+          </a:p>
+          <a:p>
+            <a:pPr algn="ctr" indent="0" marL="0">
+              <a:buNone/>
+            </a:pPr>
+            <a:r>
+              <a:rPr lang="en-US" sz="1300" b="1" dirty="0">
+                <a:solidFill>
+                  <a:srgbClr val="1F2933"/>
+                </a:solidFill>
+                <a:latin typeface="Courier New" pitchFamily="34" charset="0"/>
+                <a:ea typeface="Courier New" pitchFamily="34" charset="-122"/>
+                <a:cs typeface="Courier New" pitchFamily="34" charset="-120"/>
+              </a:rPr>
+              <a:t>(Observer)</a:t>
+            </a:r>
+            <a:endParaRPr lang="en-US" sz="1300" dirty="0"/>
+          </a:p>
+        </p:txBody>
+      </p:sp>
+      <p:sp>
+        <p:nvSpPr>
+          <p:cNvPr id="11" name="Shape 8"/>
+          <p:cNvSpPr/>
+          <p:nvPr/>
+        </p:nvSpPr>
+        <p:spPr>
+          <a:xfrm>
+            <a:off x="6949440" y="1828800"/>
+            <a:ext cx="2377440" cy="731520"/>
+          </a:xfrm>
+          <a:prstGeom prst="rect">
+            <a:avLst/>
+          </a:prstGeom>
+          <a:solidFill>
+            <a:srgbClr val="FFFFFF"/>
+          </a:solidFill>
+          <a:ln w="12700">
+            <a:solidFill>
+              <a:srgbClr val="D4D8CC"/>
+            </a:solidFill>
+            <a:prstDash val="solid"/>
+          </a:ln>
+        </p:spPr>
+      </p:sp>
+      <p:sp>
+        <p:nvSpPr>
+          <p:cNvPr id="12" name="Text 9"/>
+          <p:cNvSpPr/>
+          <p:nvPr/>
+        </p:nvSpPr>
+        <p:spPr>
+          <a:xfrm>
+            <a:off x="6949440" y="1828800"/>
+            <a:ext cx="2377440" cy="731520"/>
+          </a:xfrm>
+          <a:prstGeom prst="rect">
+            <a:avLst/>
+          </a:prstGeom>
+          <a:noFill/>
+          <a:ln/>
+        </p:spPr>
+        <p:txBody>
+          <a:bodyPr wrap="square" lIns="762" tIns="762" rIns="762" bIns="762" rtlCol="0" anchor="ctr"/>
+          <a:lstStyle/>
+          <a:p>
+            <a:pPr algn="ctr" indent="0" marL="0">
+              <a:buNone/>
+            </a:pPr>
+            <a:r>
+              <a:rPr lang="en-US" sz="1400" b="1" dirty="0">
+                <a:solidFill>
+                  <a:srgbClr val="1F2933"/>
+                </a:solidFill>
+                <a:latin typeface="Courier New" pitchFamily="34" charset="0"/>
+                <a:ea typeface="Courier New" pitchFamily="34" charset="-122"/>
+                <a:cs typeface="Courier New" pitchFamily="34" charset="-120"/>
+              </a:rPr>
+              <a:t>AccountService</a:t>
+            </a:r>
+            <a:endParaRPr lang="en-US" sz="1400" dirty="0"/>
+          </a:p>
+        </p:txBody>
+      </p:sp>
+      <p:sp>
+        <p:nvSpPr>
+          <p:cNvPr id="13" name="Shape 10"/>
+          <p:cNvSpPr/>
+          <p:nvPr/>
+        </p:nvSpPr>
+        <p:spPr>
+          <a:xfrm>
+            <a:off x="6949440" y="3063240"/>
+            <a:ext cx="2377440" cy="640080"/>
+          </a:xfrm>
+          <a:prstGeom prst="rect">
+            <a:avLst/>
+          </a:prstGeom>
+          <a:solidFill>
+            <a:srgbClr val="EAF0E4"/>
+          </a:solidFill>
+          <a:ln w="19050">
+            <a:solidFill>
+              <a:srgbClr val="466A38"/>
+            </a:solidFill>
+            <a:prstDash val="solid"/>
+          </a:ln>
+        </p:spPr>
+      </p:sp>
+      <p:sp>
+        <p:nvSpPr>
+          <p:cNvPr id="14" name="Text 11"/>
+          <p:cNvSpPr/>
+          <p:nvPr/>
+        </p:nvSpPr>
+        <p:spPr>
+          <a:xfrm>
+            <a:off x="6949440" y="3063240"/>
+            <a:ext cx="2377440" cy="640080"/>
+          </a:xfrm>
+          <a:prstGeom prst="rect">
+            <a:avLst/>
+          </a:prstGeom>
+          <a:noFill/>
+          <a:ln/>
+        </p:spPr>
+        <p:txBody>
+          <a:bodyPr wrap="square" lIns="762" tIns="762" rIns="762" bIns="762" rtlCol="0" anchor="ctr"/>
+          <a:lstStyle/>
+          <a:p>
+            <a:pPr algn="ctr" indent="0" marL="0">
+              <a:buNone/>
+            </a:pPr>
+            <a:r>
+              <a:rPr lang="en-US" sz="1300" b="1" dirty="0">
+                <a:solidFill>
+                  <a:srgbClr val="1F2933"/>
+                </a:solidFill>
+                <a:latin typeface="Courier New" pitchFamily="34" charset="0"/>
+                <a:ea typeface="Courier New" pitchFamily="34" charset="-122"/>
+                <a:cs typeface="Courier New" pitchFamily="34" charset="-120"/>
+              </a:rPr>
+              <a:t>IAccountStore</a:t>
+            </a:r>
+            <a:endParaRPr lang="en-US" sz="1300" dirty="0"/>
+          </a:p>
+        </p:txBody>
+      </p:sp>
+      <p:sp>
+        <p:nvSpPr>
+          <p:cNvPr id="15" name="Shape 12"/>
+          <p:cNvSpPr/>
+          <p:nvPr/>
+        </p:nvSpPr>
+        <p:spPr>
+          <a:xfrm>
+            <a:off x="9692640" y="2971800"/>
+            <a:ext cx="1828800" cy="822960"/>
+          </a:xfrm>
+          <a:prstGeom prst="rect">
+            <a:avLst/>
+          </a:prstGeom>
+          <a:solidFill>
+            <a:srgbClr val="FFFFFF"/>
+          </a:solidFill>
+          <a:ln w="12700">
+            <a:solidFill>
+              <a:srgbClr val="D4D8CC"/>
+            </a:solidFill>
+            <a:prstDash val="solid"/>
+          </a:ln>
+        </p:spPr>
+      </p:sp>
+      <p:sp>
+        <p:nvSpPr>
+          <p:cNvPr id="16" name="Text 13"/>
+          <p:cNvSpPr/>
+          <p:nvPr/>
+        </p:nvSpPr>
+        <p:spPr>
+          <a:xfrm>
+            <a:off x="9692640" y="2971800"/>
+            <a:ext cx="1828800" cy="822960"/>
+          </a:xfrm>
+          <a:prstGeom prst="rect">
+            <a:avLst/>
+          </a:prstGeom>
+          <a:noFill/>
+          <a:ln/>
+        </p:spPr>
+        <p:txBody>
+          <a:bodyPr wrap="square" lIns="762" tIns="762" rIns="762" bIns="762" rtlCol="0" anchor="ctr"/>
+          <a:lstStyle/>
+          <a:p>
+            <a:pPr algn="ctr" indent="0" marL="0">
+              <a:buNone/>
+            </a:pPr>
+            <a:r>
+              <a:rPr lang="en-US" sz="1200" b="1" dirty="0">
+                <a:solidFill>
+                  <a:srgbClr val="1F2933"/>
+                </a:solidFill>
+                <a:latin typeface="Courier New" pitchFamily="34" charset="0"/>
+                <a:ea typeface="Courier New" pitchFamily="34" charset="-122"/>
+                <a:cs typeface="Courier New" pitchFamily="34" charset="-120"/>
+              </a:rPr>
+              <a:t>FileAccountStore</a:t>
+            </a:r>
+            <a:endParaRPr lang="en-US" sz="1200" dirty="0"/>
+          </a:p>
+          <a:p>
+            <a:pPr algn="ctr" indent="0" marL="0">
+              <a:buNone/>
+            </a:pPr>
+            <a:r>
+              <a:rPr lang="en-US" sz="1200" b="1" dirty="0">
+                <a:solidFill>
+                  <a:srgbClr val="1F2933"/>
+                </a:solidFill>
+                <a:latin typeface="Courier New" pitchFamily="34" charset="0"/>
+                <a:ea typeface="Courier New" pitchFamily="34" charset="-122"/>
+                <a:cs typeface="Courier New" pitchFamily="34" charset="-120"/>
+              </a:rPr>
+              <a:t>(usuarios.csv)</a:t>
+            </a:r>
+            <a:endParaRPr lang="en-US" sz="1200" dirty="0"/>
+          </a:p>
+        </p:txBody>
+      </p:sp>
+      <p:sp>
+        <p:nvSpPr>
+          <p:cNvPr id="17" name="Shape 14"/>
+          <p:cNvSpPr/>
+          <p:nvPr/>
+        </p:nvSpPr>
+        <p:spPr>
+          <a:xfrm>
+            <a:off x="9692640" y="1828800"/>
+            <a:ext cx="1828800" cy="731520"/>
+          </a:xfrm>
+          <a:prstGeom prst="rect">
+            <a:avLst/>
+          </a:prstGeom>
+          <a:solidFill>
+            <a:srgbClr val="FFFFFF"/>
+          </a:solidFill>
+          <a:ln w="12700">
+            <a:solidFill>
+              <a:srgbClr val="D4D8CC"/>
+            </a:solidFill>
+            <a:prstDash val="solid"/>
+          </a:ln>
+        </p:spPr>
+      </p:sp>
+      <p:sp>
+        <p:nvSpPr>
+          <p:cNvPr id="18" name="Text 15"/>
+          <p:cNvSpPr/>
+          <p:nvPr/>
+        </p:nvSpPr>
+        <p:spPr>
+          <a:xfrm>
+            <a:off x="9692640" y="1828800"/>
+            <a:ext cx="1828800" cy="731520"/>
+          </a:xfrm>
+          <a:prstGeom prst="rect">
+            <a:avLst/>
+          </a:prstGeom>
+          <a:noFill/>
+          <a:ln/>
+        </p:spPr>
+        <p:txBody>
+          <a:bodyPr wrap="square" lIns="762" tIns="762" rIns="762" bIns="762" rtlCol="0" anchor="ctr"/>
+          <a:lstStyle/>
+          <a:p>
+            <a:pPr algn="ctr" indent="0" marL="0">
+              <a:buNone/>
+            </a:pPr>
+            <a:r>
+              <a:rPr lang="en-US" sz="1300" dirty="0">
+                <a:solidFill>
+                  <a:srgbClr val="1F2933"/>
+                </a:solidFill>
+                <a:latin typeface="Calibri" pitchFamily="34" charset="0"/>
+                <a:ea typeface="Calibri" pitchFamily="34" charset="-122"/>
+                <a:cs typeface="Calibri" pitchFamily="34" charset="-120"/>
+              </a:rPr>
+              <a:t>Menú de la ventana</a:t>
+            </a:r>
+            <a:endParaRPr lang="en-US" sz="1300" dirty="0"/>
+          </a:p>
+          <a:p>
+            <a:pPr algn="ctr" indent="0" marL="0">
+              <a:buNone/>
+            </a:pPr>
+            <a:r>
+              <a:rPr lang="en-US" sz="1300" dirty="0">
+                <a:solidFill>
+                  <a:srgbClr val="1F2933"/>
+                </a:solidFill>
+                <a:latin typeface="Calibri" pitchFamily="34" charset="0"/>
+                <a:ea typeface="Calibri" pitchFamily="34" charset="-122"/>
+                <a:cs typeface="Calibri" pitchFamily="34" charset="-120"/>
+              </a:rPr>
+              <a:t>y consola</a:t>
+            </a:r>
+            <a:endParaRPr lang="en-US" sz="1300" dirty="0"/>
+          </a:p>
+        </p:txBody>
+      </p:sp>
+      <p:sp>
+        <p:nvSpPr>
+          <p:cNvPr id="19" name="Shape 16"/>
+          <p:cNvSpPr/>
+          <p:nvPr/>
+        </p:nvSpPr>
+        <p:spPr>
+          <a:xfrm>
+            <a:off x="3017520" y="2194560"/>
+            <a:ext cx="640080" cy="0"/>
+          </a:xfrm>
+          <a:prstGeom prst="line">
+            <a:avLst/>
+          </a:prstGeom>
+          <a:noFill/>
+          <a:ln w="19050">
+            <a:solidFill>
+              <a:srgbClr val="466A38"/>
+            </a:solidFill>
+            <a:prstDash val="solid"/>
+            <a:tailEnd type="triangle"/>
+          </a:ln>
+        </p:spPr>
+      </p:sp>
+      <p:sp>
+        <p:nvSpPr>
+          <p:cNvPr id="20" name="Shape 17"/>
+          <p:cNvSpPr/>
+          <p:nvPr/>
+        </p:nvSpPr>
+        <p:spPr>
+          <a:xfrm>
+            <a:off x="6309360" y="2194560"/>
+            <a:ext cx="640080" cy="0"/>
+          </a:xfrm>
+          <a:prstGeom prst="line">
+            <a:avLst/>
+          </a:prstGeom>
+          <a:noFill/>
+          <a:ln w="19050">
+            <a:solidFill>
+              <a:srgbClr val="466A38"/>
+            </a:solidFill>
+            <a:prstDash val="solid"/>
+            <a:tailEnd type="triangle"/>
+          </a:ln>
+        </p:spPr>
+      </p:sp>
+      <p:sp>
+        <p:nvSpPr>
+          <p:cNvPr id="21" name="Shape 18"/>
+          <p:cNvSpPr/>
+          <p:nvPr/>
+        </p:nvSpPr>
+        <p:spPr>
+          <a:xfrm flipH="1">
+            <a:off x="9326880" y="2194560"/>
+            <a:ext cx="365760" cy="0"/>
+          </a:xfrm>
+          <a:prstGeom prst="line">
+            <a:avLst/>
+          </a:prstGeom>
+          <a:noFill/>
+          <a:ln w="19050">
+            <a:solidFill>
+              <a:srgbClr val="466A38"/>
+            </a:solidFill>
+            <a:prstDash val="solid"/>
+            <a:tailEnd type="triangle"/>
+          </a:ln>
+        </p:spPr>
+      </p:sp>
+      <p:sp>
+        <p:nvSpPr>
+          <p:cNvPr id="22" name="Shape 19"/>
+          <p:cNvSpPr/>
+          <p:nvPr/>
+        </p:nvSpPr>
+        <p:spPr>
+          <a:xfrm>
+            <a:off x="8138160" y="2560320"/>
+            <a:ext cx="0" cy="502920"/>
+          </a:xfrm>
+          <a:prstGeom prst="line">
+            <a:avLst/>
+          </a:prstGeom>
+          <a:noFill/>
+          <a:ln w="19050">
+            <a:solidFill>
+              <a:srgbClr val="466A38"/>
+            </a:solidFill>
+            <a:prstDash val="solid"/>
+            <a:tailEnd type="triangle"/>
+          </a:ln>
+        </p:spPr>
+      </p:sp>
+      <p:sp>
+        <p:nvSpPr>
+          <p:cNvPr id="23" name="Shape 20"/>
+          <p:cNvSpPr/>
+          <p:nvPr/>
+        </p:nvSpPr>
+        <p:spPr>
+          <a:xfrm flipH="1">
+            <a:off x="9326880" y="3383280"/>
+            <a:ext cx="365760" cy="0"/>
+          </a:xfrm>
+          <a:prstGeom prst="line">
+            <a:avLst/>
+          </a:prstGeom>
+          <a:noFill/>
+          <a:ln w="19050">
+            <a:solidFill>
+              <a:srgbClr val="466A38"/>
+            </a:solidFill>
+            <a:prstDash val="solid"/>
+            <a:tailEnd type="triangle"/>
+          </a:ln>
+        </p:spPr>
+      </p:sp>
+      <p:sp>
+        <p:nvSpPr>
+          <p:cNvPr id="24" name="Shape 21"/>
+          <p:cNvSpPr/>
+          <p:nvPr/>
+        </p:nvSpPr>
+        <p:spPr>
+          <a:xfrm>
+            <a:off x="640080" y="4256532"/>
+            <a:ext cx="128016" cy="128016"/>
+          </a:xfrm>
+          <a:prstGeom prst="rect">
+            <a:avLst/>
+          </a:prstGeom>
+          <a:solidFill>
+            <a:srgbClr val="466A38"/>
+          </a:solidFill>
+          <a:ln w="6350">
+            <a:solidFill>
+              <a:srgbClr val="466A38"/>
+            </a:solidFill>
+            <a:prstDash val="solid"/>
+          </a:ln>
+        </p:spPr>
+      </p:sp>
+      <p:sp>
+        <p:nvSpPr>
+          <p:cNvPr id="25" name="Text 22"/>
+          <p:cNvSpPr/>
+          <p:nvPr/>
+        </p:nvSpPr>
+        <p:spPr>
+          <a:xfrm>
+            <a:off x="932688" y="4069080"/>
+            <a:ext cx="10588752" cy="502920"/>
+          </a:xfrm>
+          <a:prstGeom prst="rect">
+            <a:avLst/>
+          </a:prstGeom>
+          <a:noFill/>
+          <a:ln/>
+        </p:spPr>
+        <p:txBody>
+          <a:bodyPr wrap="square" lIns="0" tIns="0" rIns="0" bIns="0" rtlCol="0" anchor="ctr"/>
+          <a:lstStyle/>
+          <a:p>
+            <a:pPr indent="0" marL="0">
+              <a:buNone/>
+            </a:pPr>
+            <a:r>
+              <a:rPr lang="en-US" sz="1700" dirty="0">
+                <a:solidFill>
+                  <a:srgbClr val="1F2933"/>
+                </a:solidFill>
+                <a:latin typeface="Calibri" pitchFamily="34" charset="0"/>
+                <a:ea typeface="Calibri" pitchFamily="34" charset="-122"/>
+                <a:cs typeface="Calibri" pitchFamily="34" charset="-120"/>
+              </a:rPr>
+              <a:t>Se entra con el nombre; el id lo asigna el sistema y no hay contraseña</a:t>
+            </a:r>
+            <a:endParaRPr lang="en-US" sz="1700" dirty="0"/>
+          </a:p>
+        </p:txBody>
+      </p:sp>
+      <p:sp>
+        <p:nvSpPr>
+          <p:cNvPr id="26" name="Shape 23"/>
+          <p:cNvSpPr/>
+          <p:nvPr/>
+        </p:nvSpPr>
+        <p:spPr>
+          <a:xfrm>
+            <a:off x="640080" y="4759452"/>
+            <a:ext cx="128016" cy="128016"/>
+          </a:xfrm>
+          <a:prstGeom prst="rect">
+            <a:avLst/>
+          </a:prstGeom>
+          <a:solidFill>
+            <a:srgbClr val="466A38"/>
+          </a:solidFill>
+          <a:ln w="6350">
+            <a:solidFill>
+              <a:srgbClr val="466A38"/>
+            </a:solidFill>
+            <a:prstDash val="solid"/>
+          </a:ln>
+        </p:spPr>
+      </p:sp>
+      <p:sp>
+        <p:nvSpPr>
+          <p:cNvPr id="27" name="Text 24"/>
+          <p:cNvSpPr/>
+          <p:nvPr/>
+        </p:nvSpPr>
+        <p:spPr>
+          <a:xfrm>
+            <a:off x="932688" y="4572000"/>
+            <a:ext cx="10588752" cy="502920"/>
+          </a:xfrm>
+          <a:prstGeom prst="rect">
+            <a:avLst/>
+          </a:prstGeom>
+          <a:noFill/>
+          <a:ln/>
+        </p:spPr>
+        <p:txBody>
+          <a:bodyPr wrap="square" lIns="0" tIns="0" rIns="0" bIns="0" rtlCol="0" anchor="ctr"/>
+          <a:lstStyle/>
+          <a:p>
+            <a:pPr indent="0" marL="0">
+              <a:buNone/>
+            </a:pPr>
+            <a:r>
+              <a:rPr lang="en-US" sz="1700" dirty="0">
+                <a:solidFill>
+                  <a:srgbClr val="1F2933"/>
+                </a:solidFill>
+                <a:latin typeface="Calibri" pitchFamily="34" charset="0"/>
+                <a:ea typeface="Calibri" pitchFamily="34" charset="-122"/>
+                <a:cs typeface="Calibri" pitchFamily="34" charset="-120"/>
+              </a:rPr>
+              <a:t>3 puntos por victoria y 1 por empate; ranking por puntos, victorias y nombre</a:t>
+            </a:r>
+            <a:endParaRPr lang="en-US" sz="1700" dirty="0"/>
+          </a:p>
+        </p:txBody>
+      </p:sp>
+      <p:sp>
+        <p:nvSpPr>
+          <p:cNvPr id="28" name="Shape 25"/>
+          <p:cNvSpPr/>
+          <p:nvPr/>
+        </p:nvSpPr>
+        <p:spPr>
+          <a:xfrm>
+            <a:off x="640080" y="5262372"/>
+            <a:ext cx="128016" cy="128016"/>
+          </a:xfrm>
+          <a:prstGeom prst="rect">
+            <a:avLst/>
+          </a:prstGeom>
+          <a:solidFill>
+            <a:srgbClr val="466A38"/>
+          </a:solidFill>
+          <a:ln w="6350">
+            <a:solidFill>
+              <a:srgbClr val="466A38"/>
+            </a:solidFill>
+            <a:prstDash val="solid"/>
+          </a:ln>
+        </p:spPr>
+      </p:sp>
+      <p:sp>
+        <p:nvSpPr>
+          <p:cNvPr id="29" name="Text 26"/>
+          <p:cNvSpPr/>
+          <p:nvPr/>
+        </p:nvSpPr>
+        <p:spPr>
+          <a:xfrm>
+            <a:off x="932688" y="5074920"/>
+            <a:ext cx="10588752" cy="502920"/>
+          </a:xfrm>
+          <a:prstGeom prst="rect">
+            <a:avLst/>
+          </a:prstGeom>
+          <a:noFill/>
+          <a:ln/>
+        </p:spPr>
+        <p:txBody>
+          <a:bodyPr wrap="square" lIns="0" tIns="0" rIns="0" bIns="0" rtlCol="0" anchor="ctr"/>
+          <a:lstStyle/>
+          <a:p>
+            <a:pPr indent="0" marL="0">
+              <a:buNone/>
+            </a:pPr>
+            <a:r>
+              <a:rPr lang="en-US" sz="1700" dirty="0">
+                <a:solidFill>
+                  <a:srgbClr val="1F2933"/>
+                </a:solidFill>
+                <a:latin typeface="Calibri" pitchFamily="34" charset="0"/>
+                <a:ea typeface="Calibri" pitchFamily="34" charset="-122"/>
+                <a:cs typeface="Calibri" pitchFamily="34" charset="-120"/>
+              </a:rPr>
+              <a:t>Deshacer el mate devuelve los puntos y rehacerlo los vuelve a sumar</a:t>
+            </a:r>
+            <a:endParaRPr lang="en-US" sz="1700" dirty="0"/>
+          </a:p>
+        </p:txBody>
+      </p:sp>
+      <p:sp>
+        <p:nvSpPr>
+          <p:cNvPr id="30" name="Shape 27"/>
+          <p:cNvSpPr/>
+          <p:nvPr/>
+        </p:nvSpPr>
+        <p:spPr>
+          <a:xfrm>
+            <a:off x="640080" y="5765292"/>
+            <a:ext cx="128016" cy="128016"/>
+          </a:xfrm>
+          <a:prstGeom prst="rect">
+            <a:avLst/>
+          </a:prstGeom>
+          <a:solidFill>
+            <a:srgbClr val="466A38"/>
+          </a:solidFill>
+          <a:ln w="6350">
+            <a:solidFill>
+              <a:srgbClr val="466A38"/>
+            </a:solidFill>
+            <a:prstDash val="solid"/>
+          </a:ln>
+        </p:spPr>
+      </p:sp>
+      <p:sp>
+        <p:nvSpPr>
+          <p:cNvPr id="31" name="Text 28"/>
+          <p:cNvSpPr/>
+          <p:nvPr/>
+        </p:nvSpPr>
+        <p:spPr>
+          <a:xfrm>
+            <a:off x="932688" y="5577840"/>
+            <a:ext cx="10588752" cy="502920"/>
+          </a:xfrm>
+          <a:prstGeom prst="rect">
+            <a:avLst/>
+          </a:prstGeom>
+          <a:noFill/>
+          <a:ln/>
+        </p:spPr>
+        <p:txBody>
+          <a:bodyPr wrap="square" lIns="0" tIns="0" rIns="0" bIns="0" rtlCol="0" anchor="ctr"/>
+          <a:lstStyle/>
+          <a:p>
+            <a:pPr indent="0" marL="0">
+              <a:buNone/>
+            </a:pPr>
+            <a:r>
+              <a:rPr lang="en-US" sz="1700" dirty="0">
+                <a:solidFill>
+                  <a:srgbClr val="1F2933"/>
+                </a:solidFill>
+                <a:latin typeface="Calibri" pitchFamily="34" charset="0"/>
+                <a:ea typeface="Calibri" pitchFamily="34" charset="-122"/>
+                <a:cs typeface="Calibri" pitchFamily="34" charset="-120"/>
+              </a:rPr>
+              <a:t>Contra la IA solo suma la persona, juegue con blancas o con negras</a:t>
+            </a:r>
+            <a:endParaRPr lang="en-US" sz="1700" dirty="0"/>
+          </a:p>
+        </p:txBody>
+      </p:sp>
+    </p:spTree>
+  </p:cSld>
+  <p:clrMapOvr>
+    <a:masterClrMapping/>
+  </p:clrMapOvr>
+</p:sld>
+</file>
+
+<file path=ppt/slides/slide18.xml><?xml version="1.0" encoding="utf-8"?>
+<p:sld xmlns:a="http://schemas.openxmlformats.org/drawingml/2006/main" xmlns:r="http://schemas.openxmlformats.org/officeDocument/2006/relationships" xmlns:p="http://schemas.openxmlformats.org/presentationml/2006/main">
+  <p:cSld name="Slide 18">
+    <p:bg>
+      <p:bgPr>
+        <a:solidFill>
+          <a:srgbClr val="FFFFFF"/>
+        </a:solidFill>
+      </p:bgPr>
+    </p:bg>
+    <p:spTree>
+      <p:nvGrpSpPr>
+        <p:cNvPr id="1" name=""/>
+        <p:cNvGrpSpPr/>
+        <p:nvPr/>
+      </p:nvGrpSpPr>
+      <p:grpSpPr>
+        <a:xfrm>
+          <a:off x="0" y="0"/>
+          <a:ext cx="0" cy="0"/>
+          <a:chOff x="0" y="0"/>
+          <a:chExt cx="0" cy="0"/>
+        </a:xfrm>
+      </p:grpSpPr>
+      <p:sp>
+        <p:nvSpPr>
+          <p:cNvPr id="2" name="Text 0"/>
+          <p:cNvSpPr/>
+          <p:nvPr/>
+        </p:nvSpPr>
+        <p:spPr>
+          <a:xfrm>
+            <a:off x="640080" y="384048"/>
+            <a:ext cx="8229600" cy="274320"/>
+          </a:xfrm>
+          <a:prstGeom prst="rect">
+            <a:avLst/>
+          </a:prstGeom>
+          <a:noFill/>
+          <a:ln/>
+        </p:spPr>
+        <p:txBody>
+          <a:bodyPr wrap="square" lIns="0" tIns="0" rIns="0" bIns="0" rtlCol="0" anchor="ctr"/>
+          <a:lstStyle/>
+          <a:p>
+            <a:pPr indent="0" marL="0">
+              <a:buNone/>
+            </a:pPr>
+            <a:r>
+              <a:rPr lang="en-US" sz="1200" b="1" spc="300" kern="0" dirty="0">
+                <a:solidFill>
+                  <a:srgbClr val="466A38"/>
+                </a:solidFill>
+                <a:latin typeface="Calibri" pitchFamily="34" charset="0"/>
+                <a:ea typeface="Calibri" pitchFamily="34" charset="-122"/>
+                <a:cs typeface="Calibri" pitchFamily="34" charset="-120"/>
+              </a:rPr>
+              <a:t>DECISIONES</a:t>
+            </a:r>
+            <a:endParaRPr lang="en-US" sz="1200" dirty="0"/>
+          </a:p>
+        </p:txBody>
+      </p:sp>
+      <p:sp>
+        <p:nvSpPr>
+          <p:cNvPr id="3" name="Text 1"/>
+          <p:cNvSpPr/>
+          <p:nvPr/>
+        </p:nvSpPr>
+        <p:spPr>
+          <a:xfrm>
+            <a:off x="640080" y="713232"/>
+            <a:ext cx="10881360" cy="777240"/>
+          </a:xfrm>
+          <a:prstGeom prst="rect">
+            <a:avLst/>
+          </a:prstGeom>
+          <a:noFill/>
+          <a:ln/>
+        </p:spPr>
+        <p:txBody>
+          <a:bodyPr wrap="square" lIns="0" tIns="0" rIns="0" bIns="0" rtlCol="0" anchor="t"/>
+          <a:lstStyle/>
+          <a:p>
+            <a:pPr indent="0" marL="0">
+              <a:buNone/>
+            </a:pPr>
+            <a:r>
+              <a:rPr lang="en-US" sz="3000" b="1" dirty="0">
+                <a:solidFill>
+                  <a:srgbClr val="1F2933"/>
+                </a:solidFill>
+                <a:latin typeface="Cambria" pitchFamily="34" charset="0"/>
+                <a:ea typeface="Cambria" pitchFamily="34" charset="-122"/>
+                <a:cs typeface="Cambria" pitchFamily="34" charset="-120"/>
+              </a:rPr>
+              <a:t>Qué se decidió y cuándo se rompería</a:t>
+            </a:r>
+            <a:endParaRPr lang="en-US" sz="3000" dirty="0"/>
+          </a:p>
+        </p:txBody>
+      </p:sp>
+      <p:sp>
+        <p:nvSpPr>
+          <p:cNvPr id="4" name="Text 2"/>
+          <p:cNvSpPr/>
+          <p:nvPr/>
+        </p:nvSpPr>
+        <p:spPr>
+          <a:xfrm>
+            <a:off x="640080" y="6419088"/>
+            <a:ext cx="7315200" cy="228600"/>
+          </a:xfrm>
+          <a:prstGeom prst="rect">
+            <a:avLst/>
+          </a:prstGeom>
+          <a:noFill/>
+          <a:ln/>
+        </p:spPr>
+        <p:txBody>
+          <a:bodyPr wrap="square" lIns="0" tIns="0" rIns="0" bIns="0" rtlCol="0" anchor="ctr"/>
+          <a:lstStyle/>
+          <a:p>
+            <a:pPr indent="0" marL="0">
+              <a:buNone/>
+            </a:pPr>
+            <a:r>
+              <a:rPr lang="en-US" sz="1000" dirty="0">
+                <a:solidFill>
+                  <a:srgbClr val="6B7280"/>
+                </a:solidFill>
+                <a:latin typeface="Calibri" pitchFamily="34" charset="0"/>
+                <a:ea typeface="Calibri" pitchFamily="34" charset="-122"/>
+                <a:cs typeface="Calibri" pitchFamily="34" charset="-120"/>
+              </a:rPr>
+              <a:t>TP Ajedrez · Ingeniería de Software · UADE</a:t>
+            </a:r>
+            <a:endParaRPr lang="en-US" sz="1000" dirty="0"/>
+          </a:p>
+        </p:txBody>
+      </p:sp>
+      <p:sp>
+        <p:nvSpPr>
+          <p:cNvPr id="5" name="Text 3"/>
+          <p:cNvSpPr/>
+          <p:nvPr/>
+        </p:nvSpPr>
+        <p:spPr>
+          <a:xfrm>
+            <a:off x="10881360" y="6419088"/>
+            <a:ext cx="640080" cy="228600"/>
+          </a:xfrm>
+          <a:prstGeom prst="rect">
+            <a:avLst/>
+          </a:prstGeom>
+          <a:noFill/>
+          <a:ln/>
+        </p:spPr>
+        <p:txBody>
+          <a:bodyPr wrap="square" lIns="0" tIns="0" rIns="0" bIns="0" rtlCol="0" anchor="ctr"/>
+          <a:lstStyle/>
+          <a:p>
+            <a:pPr algn="r" indent="0" marL="0">
+              <a:buNone/>
+            </a:pPr>
+            <a:r>
+              <a:rPr lang="en-US" sz="1000" dirty="0">
+                <a:solidFill>
+                  <a:srgbClr val="6B7280"/>
+                </a:solidFill>
+                <a:latin typeface="Calibri" pitchFamily="34" charset="0"/>
+                <a:ea typeface="Calibri" pitchFamily="34" charset="-122"/>
+                <a:cs typeface="Calibri" pitchFamily="34" charset="-120"/>
+              </a:rPr>
+              <a:t>18</a:t>
+            </a:r>
+            <a:endParaRPr lang="en-US" sz="1000" dirty="0"/>
+          </a:p>
+        </p:txBody>
+      </p:sp>
       <p:graphicFrame>
         <p:nvGraphicFramePr>
-          <p:cNvPr id="18" name="Table 0"/>
+          <p:cNvPr id="19" name="Table 0"/>
           <p:cNvGraphicFramePr>
             <a:graphicFrameLocks noGrp="1"/>
           </p:cNvGraphicFramePr>
@@ -9499,7 +10587,7 @@
                 <a:gridCol w="5394960"/>
                 <a:gridCol w="5486400"/>
               </a:tblGrid>
-              <a:tr h="566928">
+              <a:tr h="502920">
                 <a:tc>
                   <a:txBody>
                     <a:bodyPr/>
@@ -9637,7 +10725,7 @@
                   </a:tcPr>
                 </a:tc>
               </a:tr>
-              <a:tr h="566928">
+              <a:tr h="502920">
                 <a:tc>
                   <a:txBody>
                     <a:bodyPr/>
@@ -9769,7 +10857,7 @@
                   </a:tcPr>
                 </a:tc>
               </a:tr>
-              <a:tr h="566928">
+              <a:tr h="502920">
                 <a:tc>
                   <a:txBody>
                     <a:bodyPr/>
@@ -9901,7 +10989,7 @@
                   </a:tcPr>
                 </a:tc>
               </a:tr>
-              <a:tr h="566928">
+              <a:tr h="502920">
                 <a:tc>
                   <a:txBody>
                     <a:bodyPr/>
@@ -10033,7 +11121,7 @@
                   </a:tcPr>
                 </a:tc>
               </a:tr>
-              <a:tr h="566928">
+              <a:tr h="502920">
                 <a:tc>
                   <a:txBody>
                     <a:bodyPr/>
@@ -10165,7 +11253,7 @@
                   </a:tcPr>
                 </a:tc>
               </a:tr>
-              <a:tr h="566928">
+              <a:tr h="502920">
                 <a:tc>
                   <a:txBody>
                     <a:bodyPr/>
@@ -10297,7 +11385,7 @@
                   </a:tcPr>
                 </a:tc>
               </a:tr>
-              <a:tr h="566928">
+              <a:tr h="502920">
                 <a:tc>
                   <a:txBody>
                     <a:bodyPr/>
@@ -10429,6 +11517,138 @@
                   </a:tcPr>
                 </a:tc>
               </a:tr>
+              <a:tr h="502920">
+                <a:tc>
+                  <a:txBody>
+                    <a:bodyPr/>
+                    <a:lstStyle/>
+                    <a:p>
+                      <a:pPr indent="0" marL="0">
+                        <a:buNone/>
+                      </a:pPr>
+                      <a:r>
+                        <a:rPr lang="en-US" sz="1500" dirty="0">
+                          <a:solidFill>
+                            <a:srgbClr val="1F2933"/>
+                          </a:solidFill>
+                          <a:latin typeface="Calibri" pitchFamily="34" charset="0"/>
+                          <a:ea typeface="Calibri" pitchFamily="34" charset="-122"/>
+                          <a:cs typeface="Calibri" pitchFamily="34" charset="-120"/>
+                        </a:rPr>
+                        <a:t>Usuarios detrás de su propio puerto</a:t>
+                      </a:r>
+                      <a:endParaRPr lang="en-US" sz="1500" dirty="0">
+                        <a:latin typeface="Calibri" charset="0"/>
+                        <a:ea typeface="Calibri" charset="0"/>
+                        <a:cs typeface="Calibri" charset="0"/>
+                      </a:endParaRPr>
+                    </a:p>
+                  </a:txBody>
+                  <a:tcPr marL="137160" marR="137160" marT="45720" marB="45720" anchor="ctr">
+                    <a:lnL w="9525" cap="flat" cmpd="sng" algn="ctr">
+                      <a:solidFill>
+                        <a:srgbClr val="D4D8CC"/>
+                      </a:solidFill>
+                      <a:prstDash val="solid"/>
+                      <a:round/>
+                      <a:headEnd type="none" w="med" len="med"/>
+                      <a:tailEnd type="none" w="med" len="med"/>
+                    </a:lnL>
+                    <a:lnR w="9525" cap="flat" cmpd="sng" algn="ctr">
+                      <a:solidFill>
+                        <a:srgbClr val="D4D8CC"/>
+                      </a:solidFill>
+                      <a:prstDash val="solid"/>
+                      <a:round/>
+                      <a:headEnd type="none" w="med" len="med"/>
+                      <a:tailEnd type="none" w="med" len="med"/>
+                    </a:lnR>
+                    <a:lnT w="9525" cap="flat" cmpd="sng" algn="ctr">
+                      <a:solidFill>
+                        <a:srgbClr val="D4D8CC"/>
+                      </a:solidFill>
+                      <a:prstDash val="solid"/>
+                      <a:round/>
+                      <a:headEnd type="none" w="med" len="med"/>
+                      <a:tailEnd type="none" w="med" len="med"/>
+                    </a:lnT>
+                    <a:lnB w="9525" cap="flat" cmpd="sng" algn="ctr">
+                      <a:solidFill>
+                        <a:srgbClr val="D4D8CC"/>
+                      </a:solidFill>
+                      <a:prstDash val="solid"/>
+                      <a:round/>
+                      <a:headEnd type="none" w="med" len="med"/>
+                      <a:tailEnd type="none" w="med" len="med"/>
+                    </a:lnB>
+                  </a:tcPr>
+                </a:tc>
+                <a:tc>
+                  <a:txBody>
+                    <a:bodyPr/>
+                    <a:lstStyle/>
+                    <a:p>
+                      <a:pPr indent="0" marL="0">
+                        <a:buNone/>
+                      </a:pPr>
+                      <a:r>
+                        <a:rPr lang="en-US" sz="1500" dirty="0">
+                          <a:solidFill>
+                            <a:srgbClr val="1F2933"/>
+                          </a:solidFill>
+                          <a:latin typeface="Calibri" pitchFamily="34" charset="0"/>
+                          <a:ea typeface="Calibri" pitchFamily="34" charset="-122"/>
+                          <a:cs typeface="Calibri" pitchFamily="34" charset="-120"/>
+                        </a:rPr>
+                        <a:t>Con usuarios reales: contraseña y base de datos</a:t>
+                      </a:r>
+                      <a:endParaRPr lang="en-US" sz="1500" dirty="0">
+                        <a:latin typeface="Calibri" charset="0"/>
+                        <a:ea typeface="Calibri" charset="0"/>
+                        <a:cs typeface="Calibri" charset="0"/>
+                      </a:endParaRPr>
+                    </a:p>
+                  </a:txBody>
+                  <a:tcPr marL="137160" marR="137160" marT="45720" marB="45720" anchor="ctr">
+                    <a:lnL w="9525" cap="flat" cmpd="sng" algn="ctr">
+                      <a:solidFill>
+                        <a:srgbClr val="D4D8CC"/>
+                      </a:solidFill>
+                      <a:prstDash val="solid"/>
+                      <a:round/>
+                      <a:headEnd type="none" w="med" len="med"/>
+                      <a:tailEnd type="none" w="med" len="med"/>
+                    </a:lnL>
+                    <a:lnR w="9525" cap="flat" cmpd="sng" algn="ctr">
+                      <a:solidFill>
+                        <a:srgbClr val="D4D8CC"/>
+                      </a:solidFill>
+                      <a:prstDash val="solid"/>
+                      <a:round/>
+                      <a:headEnd type="none" w="med" len="med"/>
+                      <a:tailEnd type="none" w="med" len="med"/>
+                    </a:lnR>
+                    <a:lnT w="9525" cap="flat" cmpd="sng" algn="ctr">
+                      <a:solidFill>
+                        <a:srgbClr val="D4D8CC"/>
+                      </a:solidFill>
+                      <a:prstDash val="solid"/>
+                      <a:round/>
+                      <a:headEnd type="none" w="med" len="med"/>
+                      <a:tailEnd type="none" w="med" len="med"/>
+                    </a:lnT>
+                    <a:lnB w="9525" cap="flat" cmpd="sng" algn="ctr">
+                      <a:solidFill>
+                        <a:srgbClr val="D4D8CC"/>
+                      </a:solidFill>
+                      <a:prstDash val="solid"/>
+                      <a:round/>
+                      <a:headEnd type="none" w="med" len="med"/>
+                      <a:tailEnd type="none" w="med" len="med"/>
+                    </a:lnB>
+                  </a:tcPr>
+                </a:tc>
+              </a:tr>
             </a:tbl>
           </a:graphicData>
         </a:graphic>
@@ -10480,9 +11700,9 @@
 </p:sld>
 </file>
 
-<file path=ppt/slides/slide18.xml><?xml version="1.0" encoding="utf-8"?>
+<file path=ppt/slides/slide19.xml><?xml version="1.0" encoding="utf-8"?>
 <p:sld xmlns:a="http://schemas.openxmlformats.org/drawingml/2006/main" xmlns:r="http://schemas.openxmlformats.org/officeDocument/2006/relationships" xmlns:p="http://schemas.openxmlformats.org/presentationml/2006/main">
-  <p:cSld name="Slide 18">
+  <p:cSld name="Slide 19">
     <p:bg>
       <p:bgPr>
         <a:solidFill>
@@ -10654,7 +11874,7 @@
                 <a:ea typeface="Calibri" pitchFamily="34" charset="-122"/>
                 <a:cs typeface="Calibri" pitchFamily="34" charset="-120"/>
               </a:rPr>
-              <a:t>Dos jugadores: enroque y coronación</a:t>
+              <a:t>Menú: usuarios, 1 contra 1 o contra la IA</a:t>
             </a:r>
             <a:endParaRPr lang="en-US" sz="2000" dirty="0"/>
           </a:p>
@@ -10732,7 +11952,7 @@
                 <a:ea typeface="Calibri" pitchFamily="34" charset="-122"/>
                 <a:cs typeface="Calibri" pitchFamily="34" charset="-120"/>
               </a:rPr>
-              <a:t>Captura al paso</a:t>
+              <a:t>Enroque, coronación y captura al paso</a:t>
             </a:r>
             <a:endParaRPr lang="en-US" sz="2000" dirty="0"/>
           </a:p>
@@ -10810,7 +12030,7 @@
                 <a:ea typeface="Calibri" pitchFamily="34" charset="-122"/>
                 <a:cs typeface="Calibri" pitchFamily="34" charset="-120"/>
               </a:rPr>
-              <a:t>Deshacer y rehacer</a:t>
+              <a:t>Deshacer, rehacer y ranking</a:t>
             </a:r>
             <a:endParaRPr lang="en-US" sz="2000" dirty="0"/>
           </a:p>
@@ -10888,7 +12108,7 @@
                 <a:ea typeface="Calibri" pitchFamily="34" charset="-122"/>
                 <a:cs typeface="Calibri" pitchFamily="34" charset="-120"/>
               </a:rPr>
-              <a:t>Contra la IA en nivel difícil</a:t>
+              <a:t>Contra la IA con negras: el tablero se gira</a:t>
             </a:r>
             <a:endParaRPr lang="en-US" sz="2000" dirty="0"/>
           </a:p>
@@ -12454,7 +13674,7 @@
                 <a:ea typeface="Calibri" pitchFamily="34" charset="-122"/>
                 <a:cs typeface="Calibri" pitchFamily="34" charset="-120"/>
               </a:rPr>
-              <a:t>ConsoleRenderer</a:t>
+              <a:t>Consola y ventana Swing</a:t>
             </a:r>
             <a:endParaRPr lang="en-US" sz="1600" dirty="0"/>
           </a:p>
@@ -12493,7 +13713,7 @@
                 <a:ea typeface="Calibri" pitchFamily="34" charset="-122"/>
                 <a:cs typeface="Calibri" pitchFamily="34" charset="-120"/>
               </a:rPr>
-              <a:t>SwingChessView</a:t>
+              <a:t>FileAccountStore (CSV)</a:t>
             </a:r>
             <a:endParaRPr lang="en-US" sz="1600" dirty="0"/>
           </a:p>
@@ -12738,7 +13958,7 @@
                 <a:ea typeface="Calibri" pitchFamily="34" charset="-122"/>
                 <a:cs typeface="Calibri" pitchFamily="34" charset="-120"/>
               </a:rPr>
-              <a:t>IMoveListener</a:t>
+              <a:t>Dos listeners (Observer)</a:t>
             </a:r>
             <a:endParaRPr lang="en-US" sz="1600" dirty="0"/>
           </a:p>
@@ -12777,7 +13997,7 @@
                 <a:ea typeface="Calibri" pitchFamily="34" charset="-122"/>
                 <a:cs typeface="Calibri" pitchFamily="34" charset="-120"/>
               </a:rPr>
-              <a:t>IGameStatusListener</a:t>
+              <a:t>IPromotionChooser</a:t>
             </a:r>
             <a:endParaRPr lang="en-US" sz="1600" dirty="0"/>
           </a:p>
@@ -12816,7 +14036,7 @@
                 <a:ea typeface="Calibri" pitchFamily="34" charset="-122"/>
                 <a:cs typeface="Calibri" pitchFamily="34" charset="-120"/>
               </a:rPr>
-              <a:t>IPromotionChooser</a:t>
+              <a:t>IAccountStore</a:t>
             </a:r>
             <a:endParaRPr lang="en-US" sz="1600" dirty="0"/>
           </a:p>
@@ -14845,7 +16065,7 @@
                 <a:ea typeface="Cambria" pitchFamily="34" charset="-122"/>
                 <a:cs typeface="Cambria" pitchFamily="34" charset="-120"/>
               </a:rPr>
-              <a:t>Una entrada y tres salidas</a:t>
+              <a:t>Una entrada y cuatro salidas</a:t>
             </a:r>
             <a:endParaRPr lang="en-US" sz="3000" dirty="0"/>
           </a:p>
@@ -15265,7 +16485,7 @@
         <p:spPr>
           <a:xfrm>
             <a:off x="7040880" y="2468880"/>
-            <a:ext cx="2286000" cy="694944"/>
+            <a:ext cx="2286000" cy="512064"/>
           </a:xfrm>
           <a:prstGeom prst="rect">
             <a:avLst/>
@@ -15290,7 +16510,7 @@
         <p:spPr>
           <a:xfrm>
             <a:off x="7040880" y="2468880"/>
-            <a:ext cx="2286000" cy="694944"/>
+            <a:ext cx="2286000" cy="512064"/>
           </a:xfrm>
           <a:prstGeom prst="rect">
             <a:avLst/>
@@ -15328,8 +16548,8 @@
         </p:nvSpPr>
         <p:spPr>
           <a:xfrm>
-            <a:off x="7040880" y="3310128"/>
-            <a:ext cx="2286000" cy="694944"/>
+            <a:off x="7040880" y="3090672"/>
+            <a:ext cx="2286000" cy="512064"/>
           </a:xfrm>
           <a:prstGeom prst="rect">
             <a:avLst/>
@@ -15353,8 +16573,8 @@
         </p:nvSpPr>
         <p:spPr>
           <a:xfrm>
-            <a:off x="7040880" y="3310128"/>
-            <a:ext cx="2286000" cy="694944"/>
+            <a:off x="7040880" y="3090672"/>
+            <a:ext cx="2286000" cy="512064"/>
           </a:xfrm>
           <a:prstGeom prst="rect">
             <a:avLst/>
@@ -15392,8 +16612,8 @@
         </p:nvSpPr>
         <p:spPr>
           <a:xfrm>
-            <a:off x="7040880" y="4151376"/>
-            <a:ext cx="2286000" cy="694944"/>
+            <a:off x="7040880" y="3712464"/>
+            <a:ext cx="2286000" cy="512064"/>
           </a:xfrm>
           <a:prstGeom prst="rect">
             <a:avLst/>
@@ -15417,8 +16637,8 @@
         </p:nvSpPr>
         <p:spPr>
           <a:xfrm>
-            <a:off x="7040880" y="4151376"/>
-            <a:ext cx="2286000" cy="694944"/>
+            <a:off x="7040880" y="3712464"/>
+            <a:ext cx="2286000" cy="512064"/>
           </a:xfrm>
           <a:prstGeom prst="rect">
             <a:avLst/>
@@ -15451,6 +16671,70 @@
       <p:sp>
         <p:nvSpPr>
           <p:cNvPr id="21" name="Shape 18"/>
+          <p:cNvSpPr/>
+          <p:nvPr/>
+        </p:nvSpPr>
+        <p:spPr>
+          <a:xfrm>
+            <a:off x="7040880" y="4334256"/>
+            <a:ext cx="2286000" cy="512064"/>
+          </a:xfrm>
+          <a:prstGeom prst="rect">
+            <a:avLst/>
+          </a:prstGeom>
+          <a:solidFill>
+            <a:srgbClr val="EAF0E4"/>
+          </a:solidFill>
+          <a:ln w="19050">
+            <a:solidFill>
+              <a:srgbClr val="466A38"/>
+            </a:solidFill>
+            <a:prstDash val="solid"/>
+          </a:ln>
+        </p:spPr>
+      </p:sp>
+      <p:sp>
+        <p:nvSpPr>
+          <p:cNvPr id="22" name="Text 19"/>
+          <p:cNvSpPr/>
+          <p:nvPr/>
+        </p:nvSpPr>
+        <p:spPr>
+          <a:xfrm>
+            <a:off x="7040880" y="4334256"/>
+            <a:ext cx="2286000" cy="512064"/>
+          </a:xfrm>
+          <a:prstGeom prst="rect">
+            <a:avLst/>
+          </a:prstGeom>
+          <a:noFill/>
+          <a:ln/>
+        </p:spPr>
+        <p:txBody>
+          <a:bodyPr wrap="square" lIns="762" tIns="762" rIns="762" bIns="762" rtlCol="0" anchor="ctr"/>
+          <a:lstStyle/>
+          <a:p>
+            <a:pPr algn="ctr" indent="0" marL="0">
+              <a:buNone/>
+            </a:pPr>
+            <a:r>
+              <a:rPr lang="en-US" sz="1200" b="1" dirty="0">
+                <a:solidFill>
+                  <a:srgbClr val="1F2933"/>
+                </a:solidFill>
+                <a:latin typeface="Courier New" pitchFamily="34" charset="0"/>
+                <a:ea typeface="Courier New" pitchFamily="34" charset="-122"/>
+                <a:cs typeface="Courier New" pitchFamily="34" charset="-120"/>
+              </a:rPr>
+              <a:t>IAccountStore</a:t>
+            </a:r>
+            <a:endParaRPr lang="en-US" sz="1200" dirty="0"/>
+          </a:p>
+        </p:txBody>
+      </p:sp>
+      <p:sp>
+        <p:nvSpPr>
+          <p:cNvPr id="23" name="Shape 20"/>
           <p:cNvSpPr/>
           <p:nvPr/>
         </p:nvSpPr>
@@ -15475,7 +16759,7 @@
       </p:sp>
       <p:sp>
         <p:nvSpPr>
-          <p:cNvPr id="22" name="Text 19"/>
+          <p:cNvPr id="24" name="Text 21"/>
           <p:cNvSpPr/>
           <p:nvPr/>
         </p:nvSpPr>
@@ -15514,12 +16798,6 @@
             <a:pPr algn="ctr" indent="0" marL="0">
               <a:buNone/>
             </a:pPr>
-            <a:endParaRPr lang="en-US" sz="1400" dirty="0"/>
-          </a:p>
-          <a:p>
-            <a:pPr algn="ctr" indent="0" marL="0">
-              <a:buNone/>
-            </a:pPr>
             <a:r>
               <a:rPr lang="en-US" sz="1400" dirty="0">
                 <a:solidFill>
@@ -15533,11 +16811,34 @@
             </a:r>
             <a:endParaRPr lang="en-US" sz="1400" dirty="0"/>
           </a:p>
-        </p:txBody>
-      </p:sp>
-      <p:sp>
-        <p:nvSpPr>
-          <p:cNvPr id="23" name="Shape 20"/>
+          <a:p>
+            <a:pPr algn="ctr" indent="0" marL="0">
+              <a:buNone/>
+            </a:pPr>
+            <a:endParaRPr lang="en-US" sz="1400" dirty="0"/>
+          </a:p>
+          <a:p>
+            <a:pPr algn="ctr" indent="0" marL="0">
+              <a:buNone/>
+            </a:pPr>
+            <a:r>
+              <a:rPr lang="en-US" sz="1400" dirty="0">
+                <a:solidFill>
+                  <a:srgbClr val="1F2933"/>
+                </a:solidFill>
+                <a:latin typeface="Calibri" pitchFamily="34" charset="0"/>
+                <a:ea typeface="Calibri" pitchFamily="34" charset="-122"/>
+                <a:cs typeface="Calibri" pitchFamily="34" charset="-120"/>
+              </a:rPr>
+              <a:t>FileAccountStore</a:t>
+            </a:r>
+            <a:endParaRPr lang="en-US" sz="1400" dirty="0"/>
+          </a:p>
+        </p:txBody>
+      </p:sp>
+      <p:sp>
+        <p:nvSpPr>
+          <p:cNvPr id="25" name="Shape 22"/>
           <p:cNvSpPr/>
           <p:nvPr/>
         </p:nvSpPr>
@@ -15561,7 +16862,7 @@
       </p:sp>
       <p:sp>
         <p:nvSpPr>
-          <p:cNvPr id="24" name="Shape 21"/>
+          <p:cNvPr id="26" name="Shape 23"/>
           <p:cNvSpPr/>
           <p:nvPr/>
         </p:nvSpPr>
@@ -15585,7 +16886,7 @@
       </p:sp>
       <p:sp>
         <p:nvSpPr>
-          <p:cNvPr id="25" name="Shape 22"/>
+          <p:cNvPr id="27" name="Shape 24"/>
           <p:cNvSpPr/>
           <p:nvPr/>
         </p:nvSpPr>
@@ -15609,7 +16910,7 @@
       </p:sp>
       <p:sp>
         <p:nvSpPr>
-          <p:cNvPr id="26" name="Shape 23"/>
+          <p:cNvPr id="28" name="Shape 25"/>
           <p:cNvSpPr/>
           <p:nvPr/>
         </p:nvSpPr>
@@ -15633,7 +16934,7 @@
       </p:sp>
       <p:sp>
         <p:nvSpPr>
-          <p:cNvPr id="27" name="Shape 24"/>
+          <p:cNvPr id="29" name="Shape 26"/>
           <p:cNvSpPr/>
           <p:nvPr/>
         </p:nvSpPr>
@@ -15658,7 +16959,7 @@
       </p:sp>
       <p:sp>
         <p:nvSpPr>
-          <p:cNvPr id="28" name="Text 25"/>
+          <p:cNvPr id="30" name="Text 27"/>
           <p:cNvSpPr/>
           <p:nvPr/>
         </p:nvSpPr>
@@ -15697,7 +16998,7 @@
       </p:sp>
       <p:sp>
         <p:nvSpPr>
-          <p:cNvPr id="29" name="Shape 26"/>
+          <p:cNvPr id="31" name="Shape 28"/>
           <p:cNvSpPr/>
           <p:nvPr/>
         </p:nvSpPr>
@@ -15722,7 +17023,7 @@
       </p:sp>
       <p:sp>
         <p:nvSpPr>
-          <p:cNvPr id="30" name="Text 27"/>
+          <p:cNvPr id="32" name="Text 29"/>
           <p:cNvSpPr/>
           <p:nvPr/>
         </p:nvSpPr>
@@ -15761,7 +17062,7 @@
       </p:sp>
       <p:sp>
         <p:nvSpPr>
-          <p:cNvPr id="31" name="Text 28"/>
+          <p:cNvPr id="33" name="Text 30"/>
           <p:cNvSpPr/>
           <p:nvPr/>
         </p:nvSpPr>

</xml_diff>

<commit_message>
Documentacion al dia y fuera los documentos de trabajo viejos
README, justificacion (y su docx), cambios de usuarios, lista del UML y presentacion con los
paquetes en ingles, StandardRules, el Decorator en las dos interfaces, BoardView, rehacer que
vuelve a anunciar el final y los conteos de pruebas. Se borran los planes de docs/superpowers,
ui-review.md y estado-final.md, que eran notas de trabajo y no entregables.
</commit_message>
<xml_diff>
--- a/docs/presentacion.pptx
+++ b/docs/presentacion.pptx
@@ -1664,7 +1664,7 @@
           <a:p>
             <a:r>
               <a:rPr lang="en-US" dirty="0"/>
-              <a:t>Recorrer el diagrama por paquetes: nucleo, puertos, adaptadores y ai. Señalar la interfaz IChessGame como única entrada y las estrategias de movimiento.</a:t>
+              <a:t>Recorrer el diagrama por paquetes: core (el núcleo), ports, adapters, accounts y ai. Señalar la interfaz IChessGame como única entrada y las estrategias de movimiento.</a:t>
             </a:r>
             <a:endParaRPr lang="en-US" dirty="0"/>
           </a:p>
@@ -6934,7 +6934,7 @@
                 <a:ea typeface="Calibri" pitchFamily="34" charset="-122"/>
                 <a:cs typeface="Calibri" pitchFamily="34" charset="-120"/>
               </a:rPr>
-              <a:t>Regla nueva: una clase y una línea en el armado. ChessGame no se toca (Open/Closed).</a:t>
+              <a:t>Regla nueva: una clase y una línea en StandardRules. ChessGame no se toca (Open/Closed).</a:t>
             </a:r>
             <a:endParaRPr lang="en-US" sz="1800" dirty="0"/>
           </a:p>
@@ -7864,7 +7864,7 @@
                 <a:ea typeface="Courier New" pitchFamily="34" charset="-122"/>
                 <a:cs typeface="Courier New" pitchFamily="34" charset="-120"/>
               </a:rPr>
-              <a:t>drawRules.add(</a:t>
+              <a:t>// en StandardRules:</a:t>
             </a:r>
             <a:endParaRPr lang="en-US" sz="1400" dirty="0"/>
           </a:p>
@@ -7881,7 +7881,7 @@
                 <a:ea typeface="Courier New" pitchFamily="34" charset="-122"/>
                 <a:cs typeface="Courier New" pitchFamily="34" charset="-120"/>
               </a:rPr>
-              <a:t>  new MiRegla());</a:t>
+              <a:t>new MiRegla()</a:t>
             </a:r>
             <a:endParaRPr lang="en-US" sz="1400" dirty="0"/>
           </a:p>
@@ -8203,7 +8203,7 @@
                 <a:ea typeface="Cambria" pitchFamily="34" charset="-122"/>
                 <a:cs typeface="Cambria" pitchFamily="34" charset="-120"/>
               </a:rPr>
-              <a:t>65</a:t>
+              <a:t>66</a:t>
             </a:r>
             <a:endParaRPr lang="en-US" sz="13000" dirty="0"/>
           </a:p>
@@ -8242,7 +8242,7 @@
                 <a:ea typeface="Calibri" pitchFamily="34" charset="-122"/>
                 <a:cs typeface="Calibri" pitchFamily="34" charset="-120"/>
               </a:rPr>
-              <a:t>tests del núcleo y 20 de usuarios, todos pasan</a:t>
+              <a:t>tests del núcleo y 19 de usuarios, todos pasan</a:t>
             </a:r>
             <a:endParaRPr lang="en-US" sz="2000" dirty="0"/>
           </a:p>
@@ -14393,7 +14393,7 @@
                 <a:ea typeface="Courier New" pitchFamily="34" charset="-122"/>
                 <a:cs typeface="Courier New" pitchFamily="34" charset="-120"/>
               </a:rPr>
-              <a:t>nucleo</a:t>
+              <a:t>core</a:t>
             </a:r>
             <a:pPr indent="0" marL="0">
               <a:buNone/>
@@ -14421,7 +14421,7 @@
                 <a:ea typeface="Courier New" pitchFamily="34" charset="-122"/>
                 <a:cs typeface="Courier New" pitchFamily="34" charset="-120"/>
               </a:rPr>
-              <a:t>adaptadores</a:t>
+              <a:t>adapters</a:t>
             </a:r>
             <a:pPr indent="0" marL="0">
               <a:buNone/>

</xml_diff>

<commit_message>
Integro el login separado y las skins, sin juego por LAN
El 1 contra 1 queda sin puntos y el login va antes del menu. Mantengo los arreglos de main y actualizo las pruebas y la documentacion que dependian de estos cambios.
</commit_message>
<xml_diff>
--- a/docs/presentacion.pptx
+++ b/docs/presentacion.pptx
@@ -8242,7 +8242,7 @@
                 <a:ea typeface="Calibri" pitchFamily="34" charset="-122"/>
                 <a:cs typeface="Calibri" pitchFamily="34" charset="-120"/>
               </a:rPr>
-              <a:t>tests del núcleo y 19 de usuarios, todos pasan</a:t>
+              <a:t>tests del núcleo y 20 de usuarios, todos pasan</a:t>
             </a:r>
             <a:endParaRPr lang="en-US" sz="2000" dirty="0"/>
           </a:p>
@@ -11874,7 +11874,7 @@
                 <a:ea typeface="Calibri" pitchFamily="34" charset="-122"/>
                 <a:cs typeface="Calibri" pitchFamily="34" charset="-120"/>
               </a:rPr>
-              <a:t>Menú: usuarios, 1 contra 1 o contra la IA</a:t>
+              <a:t>Login y menú: 1 contra 1 o contra la IA</a:t>
             </a:r>
             <a:endParaRPr lang="en-US" sz="2000" dirty="0"/>
           </a:p>

</xml_diff>